<commit_message>
docs(deck): mention the in-app reviewed snapshot update
</commit_message>
<xml_diff>
--- a/submission/SDC2026_LuminaNusantara_SlideDeck.pptx
+++ b/submission/SDC2026_LuminaNusantara_SlideDeck.pptx
@@ -13543,7 +13543,7 @@
                 </a:solidFill>
                 <a:latin typeface="Arial"/>
               </a:rPr>
-              <a:t>Dated, linked snapshots: DOSM job offerings, JobStreet–Randstad 2025, WEF 2025.</a:t>
+              <a:t>Dated, linked snapshots: DOSM job offerings, JobStreet–Randstad 2025, WEF 2025 — uploaded snapshots re-rank the current profile.</a:t>
             </a:r>
           </a:p>
         </p:txBody>
@@ -16905,7 +16905,7 @@
                 </a:solidFill>
                 <a:latin typeface="Arial"/>
               </a:rPr>
-              <a:t>DOSM online job offerings 2026 Q1/Q2 · JobStreet–Randstad 2025 skill signals · WEF Future of Jobs 2025 · validated manual import, source + date shown</a:t>
+              <a:t>DOSM online job offerings 2026 Q1/Q2 · JobStreet–Randstad 2025 skill signals · WEF Future of Jobs 2025 · validated manual import, source + date shown · in-app reviewed snapshot re-ranks in-session</a:t>
             </a:r>
           </a:p>
         </p:txBody>

</xml_diff>

<commit_message>
docs(deck): refresh the course counts after full catalogue coverage
</commit_message>
<xml_diff>
--- a/submission/SDC2026_LuminaNusantara_SlideDeck.pptx
+++ b/submission/SDC2026_LuminaNusantara_SlideDeck.pptx
@@ -13883,7 +13883,7 @@
                 </a:solidFill>
                 <a:latin typeface="Arial"/>
               </a:rPr>
-              <a:t>Ordered weekly steps toward free / low-cost courses; 36 course links for 30 of 54 skills.</a:t>
+              <a:t>Ordered weekly steps toward free / low-cost courses; 60 course links covering all 54 skills.</a:t>
             </a:r>
           </a:p>
         </p:txBody>
@@ -16743,7 +16743,7 @@
                 </a:solidFill>
                 <a:latin typeface="Arial"/>
               </a:rPr>
-              <a:t>Role &amp; skill catalogue · 36 linked course records · skill-to-SDG crosswalk, all versioned in JSON</a:t>
+              <a:t>Role &amp; skill catalogue · 60 linked course records · skill-to-SDG crosswalk, all versioned in JSON</a:t>
             </a:r>
           </a:p>
         </p:txBody>

</xml_diff>